<commit_message>
Rework schedule after falling behind; support % comments in lectures.txt
Split floats/C overview and bitwise into separate lectures, add
pointer/array lecture with new notes, and drop the program
organization/IO lecture. The generator now skips lines starting
with % so lectures can be commented out.

Co-Authored-By: Claude Fable 5.1 <noreply@anthropic.com>
</commit_message>
<xml_diff>
--- a/notes/05-bitwise_pointers.pptx
+++ b/notes/05-bitwise_pointers.pptx
@@ -180,7 +180,7 @@
 <file path=ppt/revisionInfo.xml><?xml version="1.0" encoding="utf-8"?>
 <p1510:revInfo xmlns:a="http://schemas.openxmlformats.org/drawingml/2006/main" xmlns:r="http://schemas.openxmlformats.org/officeDocument/2006/relationships" xmlns:p1510="http://schemas.microsoft.com/office/powerpoint/2015/10/main">
   <p1510:revLst>
-    <p1510:client id="{54C1F13C-0F2F-3040-A169-6772F606462C}" v="15" dt="2026-02-04T17:55:52.601"/>
+    <p1510:client id="{F503ED9A-D8EA-0541-8351-4B1E7B6EFECF}" v="26" dt="2026-09-21T19:30:58.396"/>
   </p1510:revLst>
 </p1510:revInfo>
 </file>
@@ -5261,7 +5261,7 @@
                 <a:ea typeface="Verdana" pitchFamily="34" charset="0"/>
                 <a:cs typeface="Consolas" pitchFamily="49" charset="0"/>
               </a:rPr>
-              <a:t>Pointers and Arrays</a:t>
+              <a:t>Bitwise Ops and Pointers</a:t>
             </a:r>
             <a:endParaRPr lang="en-US" sz="4800" b="0" dirty="0">
               <a:solidFill>

</xml_diff>